<commit_message>
update_Understanding Robust Overfitting in Adversarial Training of GNNs: A Stability and Generalization Perspective
</commit_message>
<xml_diff>
--- a/Base_Model/VAE+Diffusion/论文作图.pptx
+++ b/Base_Model/VAE+Diffusion/论文作图.pptx
@@ -8,12 +8,14 @@
     <p:notesMasterId r:id="rId4"/>
   </p:notesMasterIdLst>
   <p:handoutMasterIdLst>
-    <p:handoutMasterId r:id="rId7"/>
+    <p:handoutMasterId r:id="rId9"/>
   </p:handoutMasterIdLst>
   <p:sldIdLst>
     <p:sldId id="256" r:id="rId3"/>
     <p:sldId id="258" r:id="rId5"/>
     <p:sldId id="257" r:id="rId6"/>
+    <p:sldId id="259" r:id="rId7"/>
+    <p:sldId id="260" r:id="rId8"/>
   </p:sldIdLst>
   <p:sldSz cx="12192000" cy="6858000"/>
   <p:notesSz cx="7103745" cy="10234295"/>
@@ -6654,6 +6656,392 @@
 </p:sld>
 </file>
 
+<file path=ppt/slides/slide4.xml><?xml version="1.0" encoding="utf-8"?>
+<p:sld xmlns:a="http://schemas.openxmlformats.org/drawingml/2006/main" xmlns:r="http://schemas.openxmlformats.org/officeDocument/2006/relationships" xmlns:p="http://schemas.openxmlformats.org/presentationml/2006/main">
+  <p:cSld>
+    <p:spTree>
+      <p:nvGrpSpPr>
+        <p:cNvPr id="1" name=""/>
+        <p:cNvGrpSpPr/>
+        <p:nvPr/>
+      </p:nvGrpSpPr>
+      <p:grpSpPr/>
+      <p:sp>
+        <p:nvSpPr>
+          <p:cNvPr id="2" name="标题 1"/>
+          <p:cNvSpPr>
+            <a:spLocks noGrp="1"/>
+          </p:cNvSpPr>
+          <p:nvPr>
+            <p:ph type="ctrTitle"/>
+          </p:nvPr>
+        </p:nvSpPr>
+        <p:spPr/>
+        <p:txBody>
+          <a:bodyPr/>
+          <a:p>
+            <a:r>
+              <a:rPr lang="en-US" altLang="zh-CN"/>
+              <a:t>VQ-VAE</a:t>
+            </a:r>
+            <a:endParaRPr lang="en-US" altLang="zh-CN"/>
+          </a:p>
+        </p:txBody>
+      </p:sp>
+      <p:sp>
+        <p:nvSpPr>
+          <p:cNvPr id="3" name="副标题 2"/>
+          <p:cNvSpPr>
+            <a:spLocks noGrp="1"/>
+          </p:cNvSpPr>
+          <p:nvPr>
+            <p:ph type="subTitle" idx="1"/>
+          </p:nvPr>
+        </p:nvSpPr>
+        <p:spPr/>
+        <p:txBody>
+          <a:bodyPr/>
+          <a:p>
+            <a:endParaRPr lang="zh-CN" altLang="en-US"/>
+          </a:p>
+        </p:txBody>
+      </p:sp>
+    </p:spTree>
+  </p:cSld>
+  <p:clrMapOvr>
+    <a:masterClrMapping/>
+  </p:clrMapOvr>
+</p:sld>
+</file>
+
+<file path=ppt/slides/slide5.xml><?xml version="1.0" encoding="utf-8"?>
+<p:sld xmlns:a="http://schemas.openxmlformats.org/drawingml/2006/main" xmlns:r="http://schemas.openxmlformats.org/officeDocument/2006/relationships" xmlns:p="http://schemas.openxmlformats.org/presentationml/2006/main">
+  <p:cSld>
+    <p:spTree>
+      <p:nvGrpSpPr>
+        <p:cNvPr id="1" name=""/>
+        <p:cNvGrpSpPr/>
+        <p:nvPr/>
+      </p:nvGrpSpPr>
+      <p:grpSpPr/>
+      <p:pic>
+        <p:nvPicPr>
+          <p:cNvPr id="5" name="图片 4"/>
+          <p:cNvPicPr>
+            <a:picLocks noChangeAspect="1"/>
+          </p:cNvPicPr>
+          <p:nvPr>
+            <p:custDataLst>
+              <p:tags r:id="rId1"/>
+            </p:custDataLst>
+          </p:nvPr>
+        </p:nvPicPr>
+        <p:blipFill>
+          <a:blip r:embed="rId2"/>
+          <a:stretch>
+            <a:fillRect/>
+          </a:stretch>
+        </p:blipFill>
+        <p:spPr>
+          <a:xfrm>
+            <a:off x="0" y="426085"/>
+            <a:ext cx="4053840" cy="1707515"/>
+          </a:xfrm>
+          <a:prstGeom prst="rect">
+            <a:avLst/>
+          </a:prstGeom>
+        </p:spPr>
+      </p:pic>
+      <p:pic>
+        <p:nvPicPr>
+          <p:cNvPr id="6" name="图片 5"/>
+          <p:cNvPicPr>
+            <a:picLocks noChangeAspect="1"/>
+          </p:cNvPicPr>
+          <p:nvPr>
+            <p:custDataLst>
+              <p:tags r:id="rId3"/>
+            </p:custDataLst>
+          </p:nvPr>
+        </p:nvPicPr>
+        <p:blipFill>
+          <a:blip r:embed="rId4"/>
+          <a:stretch>
+            <a:fillRect/>
+          </a:stretch>
+        </p:blipFill>
+        <p:spPr>
+          <a:xfrm>
+            <a:off x="7845425" y="723265"/>
+            <a:ext cx="4346575" cy="1410335"/>
+          </a:xfrm>
+          <a:prstGeom prst="rect">
+            <a:avLst/>
+          </a:prstGeom>
+        </p:spPr>
+      </p:pic>
+      <p:sp>
+        <p:nvSpPr>
+          <p:cNvPr id="31" name="文本框 30"/>
+          <p:cNvSpPr txBox="1"/>
+          <p:nvPr>
+            <p:custDataLst>
+              <p:tags r:id="rId5"/>
+            </p:custDataLst>
+          </p:nvPr>
+        </p:nvSpPr>
+        <p:spPr>
+          <a:xfrm>
+            <a:off x="626745" y="2301875"/>
+            <a:ext cx="2799715" cy="575310"/>
+          </a:xfrm>
+          <a:prstGeom prst="rect">
+            <a:avLst/>
+          </a:prstGeom>
+          <a:noFill/>
+        </p:spPr>
+        <p:txBody>
+          <a:bodyPr wrap="square" rtlCol="0">
+            <a:noAutofit/>
+          </a:bodyPr>
+          <a:p>
+            <a:pPr algn="ctr"/>
+            <a:r>
+              <a:rPr lang="zh-CN" altLang="en-US" sz="1400" b="1">
+                <a:latin typeface="微软雅黑" charset="0"/>
+                <a:ea typeface="微软雅黑" charset="0"/>
+                <a:cs typeface="微软雅黑" charset="0"/>
+              </a:rPr>
+              <a:t>传统</a:t>
+            </a:r>
+            <a:r>
+              <a:rPr lang="en-US" altLang="zh-CN" sz="1400" b="1">
+                <a:latin typeface="微软雅黑" charset="0"/>
+                <a:ea typeface="微软雅黑" charset="0"/>
+                <a:cs typeface="微软雅黑" charset="0"/>
+              </a:rPr>
+              <a:t>VAE</a:t>
+            </a:r>
+            <a:br>
+              <a:rPr lang="en-US" altLang="zh-CN" sz="1400" b="1">
+                <a:latin typeface="微软雅黑" charset="0"/>
+                <a:ea typeface="微软雅黑" charset="0"/>
+                <a:cs typeface="微软雅黑" charset="0"/>
+              </a:rPr>
+            </a:br>
+            <a:r>
+              <a:rPr lang="zh-CN" altLang="en-US" sz="1400" b="1">
+                <a:latin typeface="微软雅黑" charset="0"/>
+                <a:ea typeface="微软雅黑" charset="0"/>
+                <a:cs typeface="微软雅黑" charset="0"/>
+              </a:rPr>
+              <a:t>可能会存在无用的特征</a:t>
+            </a:r>
+            <a:r>
+              <a:rPr lang="zh-CN" altLang="en-US" sz="1400" b="1">
+                <a:latin typeface="微软雅黑" charset="0"/>
+                <a:ea typeface="微软雅黑" charset="0"/>
+                <a:cs typeface="微软雅黑" charset="0"/>
+              </a:rPr>
+              <a:t>表示</a:t>
+            </a:r>
+            <a:endParaRPr lang="zh-CN" altLang="en-US" sz="1400" b="1">
+              <a:latin typeface="微软雅黑" charset="0"/>
+              <a:ea typeface="微软雅黑" charset="0"/>
+              <a:cs typeface="微软雅黑" charset="0"/>
+            </a:endParaRPr>
+          </a:p>
+        </p:txBody>
+      </p:sp>
+      <p:sp>
+        <p:nvSpPr>
+          <p:cNvPr id="7" name="文本框 6"/>
+          <p:cNvSpPr txBox="1"/>
+          <p:nvPr>
+            <p:custDataLst>
+              <p:tags r:id="rId6"/>
+            </p:custDataLst>
+          </p:nvPr>
+        </p:nvSpPr>
+        <p:spPr>
+          <a:xfrm>
+            <a:off x="4101465" y="904875"/>
+            <a:ext cx="3443605" cy="575310"/>
+          </a:xfrm>
+          <a:prstGeom prst="rect">
+            <a:avLst/>
+          </a:prstGeom>
+          <a:noFill/>
+        </p:spPr>
+        <p:txBody>
+          <a:bodyPr wrap="square" rtlCol="0">
+            <a:noAutofit/>
+          </a:bodyPr>
+          <a:p>
+            <a:pPr algn="ctr"/>
+            <a:r>
+              <a:rPr lang="zh-CN" altLang="en-US" sz="1400" b="1">
+                <a:latin typeface="微软雅黑" charset="0"/>
+                <a:ea typeface="微软雅黑" charset="0"/>
+                <a:cs typeface="微软雅黑" charset="0"/>
+              </a:rPr>
+              <a:t>矢量量化</a:t>
+            </a:r>
+            <a:r>
+              <a:rPr lang="en-US" altLang="zh-CN" sz="1400" b="1">
+                <a:latin typeface="微软雅黑" charset="0"/>
+                <a:ea typeface="微软雅黑" charset="0"/>
+                <a:cs typeface="微软雅黑" charset="0"/>
+              </a:rPr>
+              <a:t>(VQ)</a:t>
+            </a:r>
+            <a:br>
+              <a:rPr lang="en-US" altLang="zh-CN" sz="1400" b="1">
+                <a:latin typeface="微软雅黑" charset="0"/>
+                <a:ea typeface="微软雅黑" charset="0"/>
+                <a:cs typeface="微软雅黑" charset="0"/>
+              </a:rPr>
+            </a:br>
+            <a:r>
+              <a:rPr lang="zh-CN" altLang="en-US" sz="1400" b="1">
+                <a:latin typeface="微软雅黑" charset="0"/>
+                <a:ea typeface="微软雅黑" charset="0"/>
+                <a:cs typeface="微软雅黑" charset="0"/>
+              </a:rPr>
+              <a:t>数据压缩技术，通过将输入数据映射到一组预先定义的离散编码矢量来实现</a:t>
+            </a:r>
+            <a:r>
+              <a:rPr lang="zh-CN" altLang="en-US" sz="1400" b="1">
+                <a:latin typeface="微软雅黑" charset="0"/>
+                <a:ea typeface="微软雅黑" charset="0"/>
+                <a:cs typeface="微软雅黑" charset="0"/>
+              </a:rPr>
+              <a:t>压缩</a:t>
+            </a:r>
+            <a:endParaRPr lang="zh-CN" altLang="en-US" sz="1400" b="1">
+              <a:latin typeface="微软雅黑" charset="0"/>
+              <a:ea typeface="微软雅黑" charset="0"/>
+              <a:cs typeface="微软雅黑" charset="0"/>
+            </a:endParaRPr>
+          </a:p>
+        </p:txBody>
+      </p:sp>
+      <p:sp>
+        <p:nvSpPr>
+          <p:cNvPr id="9" name="文本框 8"/>
+          <p:cNvSpPr txBox="1"/>
+          <p:nvPr>
+            <p:custDataLst>
+              <p:tags r:id="rId7"/>
+            </p:custDataLst>
+          </p:nvPr>
+        </p:nvSpPr>
+        <p:spPr>
+          <a:xfrm>
+            <a:off x="8186420" y="2456180"/>
+            <a:ext cx="2799715" cy="575310"/>
+          </a:xfrm>
+          <a:prstGeom prst="rect">
+            <a:avLst/>
+          </a:prstGeom>
+          <a:noFill/>
+        </p:spPr>
+        <p:txBody>
+          <a:bodyPr wrap="square" rtlCol="0">
+            <a:noAutofit/>
+          </a:bodyPr>
+          <a:p>
+            <a:pPr algn="ctr"/>
+            <a:r>
+              <a:rPr lang="en-US" altLang="zh-CN" sz="1400" b="1">
+                <a:latin typeface="微软雅黑" charset="0"/>
+                <a:ea typeface="微软雅黑" charset="0"/>
+                <a:cs typeface="微软雅黑" charset="0"/>
+              </a:rPr>
+              <a:t>VQ-VAE</a:t>
+            </a:r>
+            <a:br>
+              <a:rPr lang="en-US" altLang="zh-CN" sz="1400" b="1">
+                <a:latin typeface="微软雅黑" charset="0"/>
+                <a:ea typeface="微软雅黑" charset="0"/>
+                <a:cs typeface="微软雅黑" charset="0"/>
+              </a:rPr>
+            </a:br>
+            <a:r>
+              <a:rPr lang="zh-CN" altLang="en-US" sz="1400" b="1">
+                <a:latin typeface="微软雅黑" charset="0"/>
+                <a:ea typeface="微软雅黑" charset="0"/>
+                <a:cs typeface="微软雅黑" charset="0"/>
+              </a:rPr>
+              <a:t>压缩</a:t>
+            </a:r>
+            <a:r>
+              <a:rPr lang="zh-CN" altLang="en-US" sz="1400" b="1">
+                <a:latin typeface="微软雅黑" charset="0"/>
+                <a:ea typeface="微软雅黑" charset="0"/>
+                <a:cs typeface="微软雅黑" charset="0"/>
+              </a:rPr>
+              <a:t>无用特征</a:t>
+            </a:r>
+            <a:br>
+              <a:rPr lang="zh-CN" altLang="en-US" sz="1400" b="1">
+                <a:latin typeface="微软雅黑" charset="0"/>
+                <a:ea typeface="微软雅黑" charset="0"/>
+                <a:cs typeface="微软雅黑" charset="0"/>
+              </a:rPr>
+            </a:br>
+            <a:r>
+              <a:rPr lang="zh-CN" altLang="en-US" sz="1400" b="1">
+                <a:latin typeface="微软雅黑" charset="0"/>
+                <a:ea typeface="微软雅黑" charset="0"/>
+                <a:cs typeface="微软雅黑" charset="0"/>
+              </a:rPr>
+              <a:t>有助于学习更具语义的稀疏表示，避免了 VAE 中的模糊问题</a:t>
+            </a:r>
+            <a:endParaRPr lang="zh-CN" altLang="en-US" sz="1400" b="1">
+              <a:latin typeface="微软雅黑" charset="0"/>
+              <a:ea typeface="微软雅黑" charset="0"/>
+              <a:cs typeface="微软雅黑" charset="0"/>
+            </a:endParaRPr>
+          </a:p>
+        </p:txBody>
+      </p:sp>
+      <p:pic>
+        <p:nvPicPr>
+          <p:cNvPr id="10" name="图片 9"/>
+          <p:cNvPicPr>
+            <a:picLocks noChangeAspect="1"/>
+          </p:cNvPicPr>
+          <p:nvPr>
+            <p:custDataLst>
+              <p:tags r:id="rId8"/>
+            </p:custDataLst>
+          </p:nvPr>
+        </p:nvPicPr>
+        <p:blipFill>
+          <a:blip r:embed="rId9"/>
+          <a:stretch>
+            <a:fillRect/>
+          </a:stretch>
+        </p:blipFill>
+        <p:spPr>
+          <a:xfrm>
+            <a:off x="1612900" y="3630930"/>
+            <a:ext cx="8966200" cy="3136900"/>
+          </a:xfrm>
+          <a:prstGeom prst="rect">
+            <a:avLst/>
+          </a:prstGeom>
+        </p:spPr>
+      </p:pic>
+    </p:spTree>
+  </p:cSld>
+  <p:clrMapOvr>
+    <a:masterClrMapping/>
+  </p:clrMapOvr>
+</p:sld>
+</file>
+
 <file path=ppt/tags/tag1.xml><?xml version="1.0" encoding="utf-8"?>
 <p:tagLst xmlns:p="http://schemas.openxmlformats.org/presentationml/2006/main">
   <p:tag name="KSO_WM_BEAUTIFY_FLAG" val=""/>
@@ -6840,7 +7228,43 @@
 </p:tagLst>
 </file>
 
+<file path=ppt/tags/tag38.xml><?xml version="1.0" encoding="utf-8"?>
+<p:tagLst xmlns:p="http://schemas.openxmlformats.org/presentationml/2006/main">
+  <p:tag name="KSO_WM_BEAUTIFY_FLAG" val=""/>
+</p:tagLst>
+</file>
+
+<file path=ppt/tags/tag39.xml><?xml version="1.0" encoding="utf-8"?>
+<p:tagLst xmlns:p="http://schemas.openxmlformats.org/presentationml/2006/main">
+  <p:tag name="KSO_WM_BEAUTIFY_FLAG" val=""/>
+</p:tagLst>
+</file>
+
 <file path=ppt/tags/tag4.xml><?xml version="1.0" encoding="utf-8"?>
+<p:tagLst xmlns:p="http://schemas.openxmlformats.org/presentationml/2006/main">
+  <p:tag name="KSO_WM_BEAUTIFY_FLAG" val=""/>
+</p:tagLst>
+</file>
+
+<file path=ppt/tags/tag40.xml><?xml version="1.0" encoding="utf-8"?>
+<p:tagLst xmlns:p="http://schemas.openxmlformats.org/presentationml/2006/main">
+  <p:tag name="KSO_WM_BEAUTIFY_FLAG" val=""/>
+</p:tagLst>
+</file>
+
+<file path=ppt/tags/tag41.xml><?xml version="1.0" encoding="utf-8"?>
+<p:tagLst xmlns:p="http://schemas.openxmlformats.org/presentationml/2006/main">
+  <p:tag name="KSO_WM_BEAUTIFY_FLAG" val=""/>
+</p:tagLst>
+</file>
+
+<file path=ppt/tags/tag42.xml><?xml version="1.0" encoding="utf-8"?>
+<p:tagLst xmlns:p="http://schemas.openxmlformats.org/presentationml/2006/main">
+  <p:tag name="KSO_WM_BEAUTIFY_FLAG" val=""/>
+</p:tagLst>
+</file>
+
+<file path=ppt/tags/tag43.xml><?xml version="1.0" encoding="utf-8"?>
 <p:tagLst xmlns:p="http://schemas.openxmlformats.org/presentationml/2006/main">
   <p:tag name="KSO_WM_BEAUTIFY_FLAG" val=""/>
 </p:tagLst>

</xml_diff>